<commit_message>
Added forensic MS to figure, reproduction text, and no-data text. Closes #57
</commit_message>
<xml_diff>
--- a/images/cover.pptx
+++ b/images/cover.pptx
@@ -8,6 +8,7 @@
     <p:sldId id="256" r:id="rId2"/>
     <p:sldId id="257" r:id="rId3"/>
     <p:sldId id="258" r:id="rId4"/>
+    <p:sldId id="259" r:id="rId5"/>
   </p:sldIdLst>
   <p:sldSz cx="6858000" cy="9906000" type="A4"/>
   <p:notesSz cx="6858000" cy="9144000"/>
@@ -245,7 +246,7 @@
           <a:p>
             <a:fld id="{51E51E49-77BA-4FD5-BB46-972D51D76856}" type="datetimeFigureOut">
               <a:rPr lang="en-US" smtClean="0"/>
-              <a:t>8/8/2025</a:t>
+              <a:t>9/10/2026</a:t>
             </a:fld>
             <a:endParaRPr lang="en-US"/>
           </a:p>
@@ -415,7 +416,7 @@
           <a:p>
             <a:fld id="{51E51E49-77BA-4FD5-BB46-972D51D76856}" type="datetimeFigureOut">
               <a:rPr lang="en-US" smtClean="0"/>
-              <a:t>8/8/2025</a:t>
+              <a:t>9/10/2026</a:t>
             </a:fld>
             <a:endParaRPr lang="en-US"/>
           </a:p>
@@ -595,7 +596,7 @@
           <a:p>
             <a:fld id="{51E51E49-77BA-4FD5-BB46-972D51D76856}" type="datetimeFigureOut">
               <a:rPr lang="en-US" smtClean="0"/>
-              <a:t>8/8/2025</a:t>
+              <a:t>9/10/2026</a:t>
             </a:fld>
             <a:endParaRPr lang="en-US"/>
           </a:p>
@@ -765,7 +766,7 @@
           <a:p>
             <a:fld id="{51E51E49-77BA-4FD5-BB46-972D51D76856}" type="datetimeFigureOut">
               <a:rPr lang="en-US" smtClean="0"/>
-              <a:t>8/8/2025</a:t>
+              <a:t>9/10/2026</a:t>
             </a:fld>
             <a:endParaRPr lang="en-US"/>
           </a:p>
@@ -1011,7 +1012,7 @@
           <a:p>
             <a:fld id="{51E51E49-77BA-4FD5-BB46-972D51D76856}" type="datetimeFigureOut">
               <a:rPr lang="en-US" smtClean="0"/>
-              <a:t>8/8/2025</a:t>
+              <a:t>9/10/2026</a:t>
             </a:fld>
             <a:endParaRPr lang="en-US"/>
           </a:p>
@@ -1243,7 +1244,7 @@
           <a:p>
             <a:fld id="{51E51E49-77BA-4FD5-BB46-972D51D76856}" type="datetimeFigureOut">
               <a:rPr lang="en-US" smtClean="0"/>
-              <a:t>8/8/2025</a:t>
+              <a:t>9/10/2026</a:t>
             </a:fld>
             <a:endParaRPr lang="en-US"/>
           </a:p>
@@ -1610,7 +1611,7 @@
           <a:p>
             <a:fld id="{51E51E49-77BA-4FD5-BB46-972D51D76856}" type="datetimeFigureOut">
               <a:rPr lang="en-US" smtClean="0"/>
-              <a:t>8/8/2025</a:t>
+              <a:t>9/10/2026</a:t>
             </a:fld>
             <a:endParaRPr lang="en-US"/>
           </a:p>
@@ -1728,7 +1729,7 @@
           <a:p>
             <a:fld id="{51E51E49-77BA-4FD5-BB46-972D51D76856}" type="datetimeFigureOut">
               <a:rPr lang="en-US" smtClean="0"/>
-              <a:t>8/8/2025</a:t>
+              <a:t>9/10/2026</a:t>
             </a:fld>
             <a:endParaRPr lang="en-US"/>
           </a:p>
@@ -1823,7 +1824,7 @@
           <a:p>
             <a:fld id="{51E51E49-77BA-4FD5-BB46-972D51D76856}" type="datetimeFigureOut">
               <a:rPr lang="en-US" smtClean="0"/>
-              <a:t>8/8/2025</a:t>
+              <a:t>9/10/2026</a:t>
             </a:fld>
             <a:endParaRPr lang="en-US"/>
           </a:p>
@@ -2100,7 +2101,7 @@
           <a:p>
             <a:fld id="{51E51E49-77BA-4FD5-BB46-972D51D76856}" type="datetimeFigureOut">
               <a:rPr lang="en-US" smtClean="0"/>
-              <a:t>8/8/2025</a:t>
+              <a:t>9/10/2026</a:t>
             </a:fld>
             <a:endParaRPr lang="en-US"/>
           </a:p>
@@ -2357,7 +2358,7 @@
           <a:p>
             <a:fld id="{51E51E49-77BA-4FD5-BB46-972D51D76856}" type="datetimeFigureOut">
               <a:rPr lang="en-US" smtClean="0"/>
-              <a:t>8/8/2025</a:t>
+              <a:t>9/10/2026</a:t>
             </a:fld>
             <a:endParaRPr lang="en-US"/>
           </a:p>
@@ -2570,7 +2571,7 @@
           <a:p>
             <a:fld id="{51E51E49-77BA-4FD5-BB46-972D51D76856}" type="datetimeFigureOut">
               <a:rPr lang="en-US" smtClean="0"/>
-              <a:t>8/8/2025</a:t>
+              <a:t>9/10/2026</a:t>
             </a:fld>
             <a:endParaRPr lang="en-US"/>
           </a:p>
@@ -3953,6 +3954,869 @@
 </p:sld>
 </file>
 
+<file path=ppt/slides/slide4.xml><?xml version="1.0" encoding="utf-8"?>
+<p:sld xmlns:a="http://schemas.openxmlformats.org/drawingml/2006/main" xmlns:r="http://schemas.openxmlformats.org/officeDocument/2006/relationships" xmlns:p="http://schemas.openxmlformats.org/presentationml/2006/main">
+  <p:cSld>
+    <p:spTree>
+      <p:nvGrpSpPr>
+        <p:cNvPr id="1" name=""/>
+        <p:cNvGrpSpPr/>
+        <p:nvPr/>
+      </p:nvGrpSpPr>
+      <p:grpSpPr>
+        <a:xfrm>
+          <a:off x="0" y="0"/>
+          <a:ext cx="0" cy="0"/>
+          <a:chOff x="0" y="0"/>
+          <a:chExt cx="0" cy="0"/>
+        </a:xfrm>
+      </p:grpSpPr>
+      <p:pic>
+        <p:nvPicPr>
+          <p:cNvPr id="5" name="Grafik 4">
+            <a:extLst>
+              <a:ext uri="{FF2B5EF4-FFF2-40B4-BE49-F238E27FC236}">
+                <a16:creationId xmlns:a16="http://schemas.microsoft.com/office/drawing/2014/main" id="{EFB25E9A-1704-A304-E286-FEFFF5BBDD21}"/>
+              </a:ext>
+            </a:extLst>
+          </p:cNvPr>
+          <p:cNvPicPr>
+            <a:picLocks noChangeAspect="1"/>
+          </p:cNvPicPr>
+          <p:nvPr/>
+        </p:nvPicPr>
+        <p:blipFill>
+          <a:blip r:embed="rId2">
+            <a:extLst>
+              <a:ext uri="{28A0092B-C50C-407E-A947-70E740481C1C}">
+                <a14:useLocalDpi xmlns:a14="http://schemas.microsoft.com/office/drawing/2010/main" val="0"/>
+              </a:ext>
+            </a:extLst>
+          </a:blip>
+          <a:stretch>
+            <a:fillRect/>
+          </a:stretch>
+        </p:blipFill>
+        <p:spPr>
+          <a:xfrm>
+            <a:off x="0" y="3313221"/>
+            <a:ext cx="6858000" cy="3279557"/>
+          </a:xfrm>
+          <a:prstGeom prst="rect">
+            <a:avLst/>
+          </a:prstGeom>
+        </p:spPr>
+      </p:pic>
+      <p:sp>
+        <p:nvSpPr>
+          <p:cNvPr id="6" name="Rechteck 5">
+            <a:extLst>
+              <a:ext uri="{FF2B5EF4-FFF2-40B4-BE49-F238E27FC236}">
+                <a16:creationId xmlns:a16="http://schemas.microsoft.com/office/drawing/2014/main" id="{7BBFE23E-4EEB-66DD-4A26-AE644627BBA0}"/>
+              </a:ext>
+            </a:extLst>
+          </p:cNvPr>
+          <p:cNvSpPr/>
+          <p:nvPr/>
+        </p:nvSpPr>
+        <p:spPr>
+          <a:xfrm>
+            <a:off x="0" y="828675"/>
+            <a:ext cx="1581150" cy="409575"/>
+          </a:xfrm>
+          <a:prstGeom prst="rect">
+            <a:avLst/>
+          </a:prstGeom>
+        </p:spPr>
+        <p:style>
+          <a:lnRef idx="2">
+            <a:schemeClr val="dk1"/>
+          </a:lnRef>
+          <a:fillRef idx="1">
+            <a:schemeClr val="lt1"/>
+          </a:fillRef>
+          <a:effectRef idx="0">
+            <a:schemeClr val="dk1"/>
+          </a:effectRef>
+          <a:fontRef idx="minor">
+            <a:schemeClr val="dk1"/>
+          </a:fontRef>
+        </p:style>
+        <p:txBody>
+          <a:bodyPr rtlCol="0" anchor="ctr"/>
+          <a:lstStyle/>
+          <a:p>
+            <a:pPr algn="ctr"/>
+            <a:r>
+              <a:rPr lang="en-US" sz="900" dirty="0"/>
+              <a:t>Preregistration, data, and code available</a:t>
+            </a:r>
+          </a:p>
+        </p:txBody>
+      </p:sp>
+      <p:sp>
+        <p:nvSpPr>
+          <p:cNvPr id="7" name="Rechteck 6">
+            <a:extLst>
+              <a:ext uri="{FF2B5EF4-FFF2-40B4-BE49-F238E27FC236}">
+                <a16:creationId xmlns:a16="http://schemas.microsoft.com/office/drawing/2014/main" id="{4EEC30D6-DCD2-5AD9-C60C-EA1F41D45C1E}"/>
+              </a:ext>
+            </a:extLst>
+          </p:cNvPr>
+          <p:cNvSpPr/>
+          <p:nvPr/>
+        </p:nvSpPr>
+        <p:spPr>
+          <a:xfrm>
+            <a:off x="1647825" y="828675"/>
+            <a:ext cx="1581150" cy="409575"/>
+          </a:xfrm>
+          <a:prstGeom prst="rect">
+            <a:avLst/>
+          </a:prstGeom>
+        </p:spPr>
+        <p:style>
+          <a:lnRef idx="2">
+            <a:schemeClr val="dk1"/>
+          </a:lnRef>
+          <a:fillRef idx="1">
+            <a:schemeClr val="lt1"/>
+          </a:fillRef>
+          <a:effectRef idx="0">
+            <a:schemeClr val="dk1"/>
+          </a:effectRef>
+          <a:fontRef idx="minor">
+            <a:schemeClr val="dk1"/>
+          </a:fontRef>
+        </p:style>
+        <p:txBody>
+          <a:bodyPr rtlCol="0" anchor="ctr"/>
+          <a:lstStyle/>
+          <a:p>
+            <a:pPr algn="ctr"/>
+            <a:r>
+              <a:rPr lang="en-US" sz="900" dirty="0"/>
+              <a:t>Data and code available</a:t>
+            </a:r>
+          </a:p>
+        </p:txBody>
+      </p:sp>
+      <p:sp>
+        <p:nvSpPr>
+          <p:cNvPr id="8" name="Rechteck 7">
+            <a:extLst>
+              <a:ext uri="{FF2B5EF4-FFF2-40B4-BE49-F238E27FC236}">
+                <a16:creationId xmlns:a16="http://schemas.microsoft.com/office/drawing/2014/main" id="{E08167BF-9ADD-D196-6C0B-C061D4FB7234}"/>
+              </a:ext>
+            </a:extLst>
+          </p:cNvPr>
+          <p:cNvSpPr/>
+          <p:nvPr/>
+        </p:nvSpPr>
+        <p:spPr>
+          <a:xfrm>
+            <a:off x="3295650" y="828675"/>
+            <a:ext cx="1581150" cy="409575"/>
+          </a:xfrm>
+          <a:prstGeom prst="rect">
+            <a:avLst/>
+          </a:prstGeom>
+        </p:spPr>
+        <p:style>
+          <a:lnRef idx="2">
+            <a:schemeClr val="dk1"/>
+          </a:lnRef>
+          <a:fillRef idx="1">
+            <a:schemeClr val="lt1"/>
+          </a:fillRef>
+          <a:effectRef idx="0">
+            <a:schemeClr val="dk1"/>
+          </a:effectRef>
+          <a:fontRef idx="minor">
+            <a:schemeClr val="dk1"/>
+          </a:fontRef>
+        </p:style>
+        <p:txBody>
+          <a:bodyPr rtlCol="0" anchor="ctr"/>
+          <a:lstStyle/>
+          <a:p>
+            <a:pPr algn="ctr"/>
+            <a:r>
+              <a:rPr lang="en-US" sz="900" dirty="0"/>
+              <a:t>Only data available</a:t>
+            </a:r>
+          </a:p>
+        </p:txBody>
+      </p:sp>
+      <p:sp>
+        <p:nvSpPr>
+          <p:cNvPr id="9" name="Rechteck 8">
+            <a:extLst>
+              <a:ext uri="{FF2B5EF4-FFF2-40B4-BE49-F238E27FC236}">
+                <a16:creationId xmlns:a16="http://schemas.microsoft.com/office/drawing/2014/main" id="{2D724061-E3D2-AD58-4F7E-BEDA2F76F12B}"/>
+              </a:ext>
+            </a:extLst>
+          </p:cNvPr>
+          <p:cNvSpPr/>
+          <p:nvPr/>
+        </p:nvSpPr>
+        <p:spPr>
+          <a:xfrm>
+            <a:off x="4943475" y="828675"/>
+            <a:ext cx="1581150" cy="409575"/>
+          </a:xfrm>
+          <a:prstGeom prst="rect">
+            <a:avLst/>
+          </a:prstGeom>
+        </p:spPr>
+        <p:style>
+          <a:lnRef idx="2">
+            <a:schemeClr val="dk1"/>
+          </a:lnRef>
+          <a:fillRef idx="1">
+            <a:schemeClr val="lt1"/>
+          </a:fillRef>
+          <a:effectRef idx="0">
+            <a:schemeClr val="dk1"/>
+          </a:effectRef>
+          <a:fontRef idx="minor">
+            <a:schemeClr val="dk1"/>
+          </a:fontRef>
+        </p:style>
+        <p:txBody>
+          <a:bodyPr rtlCol="0" anchor="ctr"/>
+          <a:lstStyle/>
+          <a:p>
+            <a:pPr algn="ctr"/>
+            <a:r>
+              <a:rPr lang="en-US" sz="900" dirty="0"/>
+              <a:t>No data available</a:t>
+            </a:r>
+          </a:p>
+        </p:txBody>
+      </p:sp>
+      <p:sp>
+        <p:nvSpPr>
+          <p:cNvPr id="10" name="Rechteck 9">
+            <a:extLst>
+              <a:ext uri="{FF2B5EF4-FFF2-40B4-BE49-F238E27FC236}">
+                <a16:creationId xmlns:a16="http://schemas.microsoft.com/office/drawing/2014/main" id="{A630A186-417C-99F3-668D-BDE6DDCC4BFE}"/>
+              </a:ext>
+            </a:extLst>
+          </p:cNvPr>
+          <p:cNvSpPr/>
+          <p:nvPr/>
+        </p:nvSpPr>
+        <p:spPr>
+          <a:xfrm>
+            <a:off x="0" y="1321224"/>
+            <a:ext cx="1581150" cy="409575"/>
+          </a:xfrm>
+          <a:prstGeom prst="rect">
+            <a:avLst/>
+          </a:prstGeom>
+        </p:spPr>
+        <p:style>
+          <a:lnRef idx="2">
+            <a:schemeClr val="dk1"/>
+          </a:lnRef>
+          <a:fillRef idx="1">
+            <a:schemeClr val="lt1"/>
+          </a:fillRef>
+          <a:effectRef idx="0">
+            <a:schemeClr val="dk1"/>
+          </a:effectRef>
+          <a:fontRef idx="minor">
+            <a:schemeClr val="dk1"/>
+          </a:fontRef>
+        </p:style>
+        <p:txBody>
+          <a:bodyPr rtlCol="0" anchor="ctr"/>
+          <a:lstStyle/>
+          <a:p>
+            <a:pPr algn="ctr"/>
+            <a:r>
+              <a:rPr lang="en-US" sz="900" dirty="0"/>
+              <a:t>Check adherence to pre-analysis plan</a:t>
+            </a:r>
+          </a:p>
+        </p:txBody>
+      </p:sp>
+      <p:sp>
+        <p:nvSpPr>
+          <p:cNvPr id="11" name="Rechteck 10">
+            <a:extLst>
+              <a:ext uri="{FF2B5EF4-FFF2-40B4-BE49-F238E27FC236}">
+                <a16:creationId xmlns:a16="http://schemas.microsoft.com/office/drawing/2014/main" id="{C083C592-D335-5831-4088-400FC148EEEB}"/>
+              </a:ext>
+            </a:extLst>
+          </p:cNvPr>
+          <p:cNvSpPr/>
+          <p:nvPr/>
+        </p:nvSpPr>
+        <p:spPr>
+          <a:xfrm>
+            <a:off x="1647825" y="1813772"/>
+            <a:ext cx="1581150" cy="409575"/>
+          </a:xfrm>
+          <a:prstGeom prst="rect">
+            <a:avLst/>
+          </a:prstGeom>
+        </p:spPr>
+        <p:style>
+          <a:lnRef idx="2">
+            <a:schemeClr val="dk1"/>
+          </a:lnRef>
+          <a:fillRef idx="1">
+            <a:schemeClr val="lt1"/>
+          </a:fillRef>
+          <a:effectRef idx="0">
+            <a:schemeClr val="dk1"/>
+          </a:effectRef>
+          <a:fontRef idx="minor">
+            <a:schemeClr val="dk1"/>
+          </a:fontRef>
+        </p:style>
+        <p:txBody>
+          <a:bodyPr rtlCol="0" anchor="ctr"/>
+          <a:lstStyle/>
+          <a:p>
+            <a:pPr algn="ctr"/>
+            <a:r>
+              <a:rPr lang="en-US" sz="900" dirty="0"/>
+              <a:t>Conduct a numerical reproduction</a:t>
+            </a:r>
+          </a:p>
+        </p:txBody>
+      </p:sp>
+      <p:sp>
+        <p:nvSpPr>
+          <p:cNvPr id="12" name="Rechteck 11">
+            <a:extLst>
+              <a:ext uri="{FF2B5EF4-FFF2-40B4-BE49-F238E27FC236}">
+                <a16:creationId xmlns:a16="http://schemas.microsoft.com/office/drawing/2014/main" id="{BD963868-942E-154D-C374-0F2BF2492D68}"/>
+              </a:ext>
+            </a:extLst>
+          </p:cNvPr>
+          <p:cNvSpPr/>
+          <p:nvPr/>
+        </p:nvSpPr>
+        <p:spPr>
+          <a:xfrm>
+            <a:off x="3295650" y="2306321"/>
+            <a:ext cx="1581150" cy="409575"/>
+          </a:xfrm>
+          <a:prstGeom prst="rect">
+            <a:avLst/>
+          </a:prstGeom>
+        </p:spPr>
+        <p:style>
+          <a:lnRef idx="2">
+            <a:schemeClr val="dk1"/>
+          </a:lnRef>
+          <a:fillRef idx="1">
+            <a:schemeClr val="lt1"/>
+          </a:fillRef>
+          <a:effectRef idx="0">
+            <a:schemeClr val="dk1"/>
+          </a:effectRef>
+          <a:fontRef idx="minor">
+            <a:schemeClr val="dk1"/>
+          </a:fontRef>
+        </p:style>
+        <p:txBody>
+          <a:bodyPr rtlCol="0" anchor="ctr"/>
+          <a:lstStyle/>
+          <a:p>
+            <a:pPr algn="ctr"/>
+            <a:r>
+              <a:rPr lang="en-US" sz="900" dirty="0"/>
+              <a:t>Conduct a recreate reproduction and robustness reproduction</a:t>
+            </a:r>
+          </a:p>
+        </p:txBody>
+      </p:sp>
+      <p:sp>
+        <p:nvSpPr>
+          <p:cNvPr id="13" name="Rechteck 12">
+            <a:extLst>
+              <a:ext uri="{FF2B5EF4-FFF2-40B4-BE49-F238E27FC236}">
+                <a16:creationId xmlns:a16="http://schemas.microsoft.com/office/drawing/2014/main" id="{F6A0BF04-D6DB-8051-AFAF-A974C4ED8E02}"/>
+              </a:ext>
+            </a:extLst>
+          </p:cNvPr>
+          <p:cNvSpPr/>
+          <p:nvPr/>
+        </p:nvSpPr>
+        <p:spPr>
+          <a:xfrm>
+            <a:off x="4943475" y="2798869"/>
+            <a:ext cx="1581150" cy="409575"/>
+          </a:xfrm>
+          <a:prstGeom prst="rect">
+            <a:avLst/>
+          </a:prstGeom>
+        </p:spPr>
+        <p:style>
+          <a:lnRef idx="2">
+            <a:schemeClr val="dk1"/>
+          </a:lnRef>
+          <a:fillRef idx="1">
+            <a:schemeClr val="lt1"/>
+          </a:fillRef>
+          <a:effectRef idx="0">
+            <a:schemeClr val="dk1"/>
+          </a:effectRef>
+          <a:fontRef idx="minor">
+            <a:schemeClr val="dk1"/>
+          </a:fontRef>
+        </p:style>
+        <p:txBody>
+          <a:bodyPr rtlCol="0" anchor="ctr"/>
+          <a:lstStyle/>
+          <a:p>
+            <a:pPr algn="ctr"/>
+            <a:r>
+              <a:rPr lang="en-US" sz="900" dirty="0"/>
+              <a:t>Conduct a replication</a:t>
+            </a:r>
+          </a:p>
+        </p:txBody>
+      </p:sp>
+      <p:sp>
+        <p:nvSpPr>
+          <p:cNvPr id="14" name="Rechteck 13">
+            <a:extLst>
+              <a:ext uri="{FF2B5EF4-FFF2-40B4-BE49-F238E27FC236}">
+                <a16:creationId xmlns:a16="http://schemas.microsoft.com/office/drawing/2014/main" id="{64D624E2-B972-436E-14FD-A3F971E50A54}"/>
+              </a:ext>
+            </a:extLst>
+          </p:cNvPr>
+          <p:cNvSpPr/>
+          <p:nvPr/>
+        </p:nvSpPr>
+        <p:spPr>
+          <a:xfrm>
+            <a:off x="4943475" y="1343024"/>
+            <a:ext cx="1581150" cy="880323"/>
+          </a:xfrm>
+          <a:prstGeom prst="rect">
+            <a:avLst/>
+          </a:prstGeom>
+        </p:spPr>
+        <p:style>
+          <a:lnRef idx="2">
+            <a:schemeClr val="dk1"/>
+          </a:lnRef>
+          <a:fillRef idx="1">
+            <a:schemeClr val="lt1"/>
+          </a:fillRef>
+          <a:effectRef idx="0">
+            <a:schemeClr val="dk1"/>
+          </a:effectRef>
+          <a:fontRef idx="minor">
+            <a:schemeClr val="dk1"/>
+          </a:fontRef>
+        </p:style>
+        <p:txBody>
+          <a:bodyPr rtlCol="0" anchor="ctr"/>
+          <a:lstStyle/>
+          <a:p>
+            <a:pPr algn="ctr"/>
+            <a:r>
+              <a:rPr lang="en-US" sz="900" dirty="0"/>
+              <a:t>Check correctness of reported results via </a:t>
+            </a:r>
+            <a:r>
+              <a:rPr lang="en-US" sz="900" dirty="0" err="1"/>
+              <a:t>statcheck</a:t>
+            </a:r>
+            <a:r>
+              <a:rPr lang="en-US" sz="900" dirty="0"/>
+              <a:t> and forensic meta-science</a:t>
+            </a:r>
+          </a:p>
+        </p:txBody>
+      </p:sp>
+      <p:cxnSp>
+        <p:nvCxnSpPr>
+          <p:cNvPr id="19" name="Gerade Verbindung mit Pfeil 18">
+            <a:extLst>
+              <a:ext uri="{FF2B5EF4-FFF2-40B4-BE49-F238E27FC236}">
+                <a16:creationId xmlns:a16="http://schemas.microsoft.com/office/drawing/2014/main" id="{DC972F30-8578-DCF0-83F7-A3934FF92581}"/>
+              </a:ext>
+            </a:extLst>
+          </p:cNvPr>
+          <p:cNvCxnSpPr>
+            <a:stCxn id="6" idx="2"/>
+            <a:endCxn id="10" idx="0"/>
+          </p:cNvCxnSpPr>
+          <p:nvPr/>
+        </p:nvCxnSpPr>
+        <p:spPr>
+          <a:xfrm>
+            <a:off x="790575" y="1238250"/>
+            <a:ext cx="0" cy="82974"/>
+          </a:xfrm>
+          <a:prstGeom prst="straightConnector1">
+            <a:avLst/>
+          </a:prstGeom>
+          <a:ln>
+            <a:tailEnd type="triangle"/>
+          </a:ln>
+        </p:spPr>
+        <p:style>
+          <a:lnRef idx="2">
+            <a:schemeClr val="dk1"/>
+          </a:lnRef>
+          <a:fillRef idx="1">
+            <a:schemeClr val="lt1"/>
+          </a:fillRef>
+          <a:effectRef idx="0">
+            <a:schemeClr val="dk1"/>
+          </a:effectRef>
+          <a:fontRef idx="minor">
+            <a:schemeClr val="dk1"/>
+          </a:fontRef>
+        </p:style>
+      </p:cxnSp>
+      <p:cxnSp>
+        <p:nvCxnSpPr>
+          <p:cNvPr id="21" name="Gerade Verbindung mit Pfeil 20">
+            <a:extLst>
+              <a:ext uri="{FF2B5EF4-FFF2-40B4-BE49-F238E27FC236}">
+                <a16:creationId xmlns:a16="http://schemas.microsoft.com/office/drawing/2014/main" id="{E531B4DA-7909-23F8-6ED9-400AACFC6D2F}"/>
+              </a:ext>
+            </a:extLst>
+          </p:cNvPr>
+          <p:cNvCxnSpPr>
+            <a:stCxn id="7" idx="2"/>
+            <a:endCxn id="11" idx="0"/>
+          </p:cNvCxnSpPr>
+          <p:nvPr/>
+        </p:nvCxnSpPr>
+        <p:spPr>
+          <a:xfrm>
+            <a:off x="2438400" y="1238250"/>
+            <a:ext cx="0" cy="575522"/>
+          </a:xfrm>
+          <a:prstGeom prst="straightConnector1">
+            <a:avLst/>
+          </a:prstGeom>
+          <a:ln>
+            <a:tailEnd type="triangle"/>
+          </a:ln>
+        </p:spPr>
+        <p:style>
+          <a:lnRef idx="2">
+            <a:schemeClr val="dk1"/>
+          </a:lnRef>
+          <a:fillRef idx="1">
+            <a:schemeClr val="lt1"/>
+          </a:fillRef>
+          <a:effectRef idx="0">
+            <a:schemeClr val="dk1"/>
+          </a:effectRef>
+          <a:fontRef idx="minor">
+            <a:schemeClr val="dk1"/>
+          </a:fontRef>
+        </p:style>
+      </p:cxnSp>
+      <p:cxnSp>
+        <p:nvCxnSpPr>
+          <p:cNvPr id="23" name="Gerade Verbindung mit Pfeil 22">
+            <a:extLst>
+              <a:ext uri="{FF2B5EF4-FFF2-40B4-BE49-F238E27FC236}">
+                <a16:creationId xmlns:a16="http://schemas.microsoft.com/office/drawing/2014/main" id="{32C58CB5-5C9E-09BB-F16F-D80BFBD0110A}"/>
+              </a:ext>
+            </a:extLst>
+          </p:cNvPr>
+          <p:cNvCxnSpPr>
+            <a:stCxn id="8" idx="2"/>
+            <a:endCxn id="12" idx="0"/>
+          </p:cNvCxnSpPr>
+          <p:nvPr/>
+        </p:nvCxnSpPr>
+        <p:spPr>
+          <a:xfrm>
+            <a:off x="4086225" y="1238250"/>
+            <a:ext cx="0" cy="1068071"/>
+          </a:xfrm>
+          <a:prstGeom prst="straightConnector1">
+            <a:avLst/>
+          </a:prstGeom>
+          <a:ln>
+            <a:tailEnd type="triangle"/>
+          </a:ln>
+        </p:spPr>
+        <p:style>
+          <a:lnRef idx="2">
+            <a:schemeClr val="dk1"/>
+          </a:lnRef>
+          <a:fillRef idx="1">
+            <a:schemeClr val="lt1"/>
+          </a:fillRef>
+          <a:effectRef idx="0">
+            <a:schemeClr val="dk1"/>
+          </a:effectRef>
+          <a:fontRef idx="minor">
+            <a:schemeClr val="dk1"/>
+          </a:fontRef>
+        </p:style>
+      </p:cxnSp>
+      <p:cxnSp>
+        <p:nvCxnSpPr>
+          <p:cNvPr id="25" name="Gerade Verbindung mit Pfeil 24">
+            <a:extLst>
+              <a:ext uri="{FF2B5EF4-FFF2-40B4-BE49-F238E27FC236}">
+                <a16:creationId xmlns:a16="http://schemas.microsoft.com/office/drawing/2014/main" id="{AC7522D6-DCBF-7E9B-06EE-6D1335EC6E80}"/>
+              </a:ext>
+            </a:extLst>
+          </p:cNvPr>
+          <p:cNvCxnSpPr>
+            <a:stCxn id="9" idx="2"/>
+            <a:endCxn id="14" idx="0"/>
+          </p:cNvCxnSpPr>
+          <p:nvPr/>
+        </p:nvCxnSpPr>
+        <p:spPr>
+          <a:xfrm>
+            <a:off x="5734050" y="1238250"/>
+            <a:ext cx="0" cy="104774"/>
+          </a:xfrm>
+          <a:prstGeom prst="straightConnector1">
+            <a:avLst/>
+          </a:prstGeom>
+          <a:ln>
+            <a:tailEnd type="triangle"/>
+          </a:ln>
+        </p:spPr>
+        <p:style>
+          <a:lnRef idx="2">
+            <a:schemeClr val="dk1"/>
+          </a:lnRef>
+          <a:fillRef idx="1">
+            <a:schemeClr val="lt1"/>
+          </a:fillRef>
+          <a:effectRef idx="0">
+            <a:schemeClr val="dk1"/>
+          </a:effectRef>
+          <a:fontRef idx="minor">
+            <a:schemeClr val="dk1"/>
+          </a:fontRef>
+        </p:style>
+      </p:cxnSp>
+      <p:cxnSp>
+        <p:nvCxnSpPr>
+          <p:cNvPr id="27" name="Gerade Verbindung mit Pfeil 26">
+            <a:extLst>
+              <a:ext uri="{FF2B5EF4-FFF2-40B4-BE49-F238E27FC236}">
+                <a16:creationId xmlns:a16="http://schemas.microsoft.com/office/drawing/2014/main" id="{3E6C1D94-C26D-9A75-7931-5465E14103B4}"/>
+              </a:ext>
+            </a:extLst>
+          </p:cNvPr>
+          <p:cNvCxnSpPr>
+            <a:stCxn id="14" idx="2"/>
+            <a:endCxn id="13" idx="0"/>
+          </p:cNvCxnSpPr>
+          <p:nvPr/>
+        </p:nvCxnSpPr>
+        <p:spPr>
+          <a:xfrm>
+            <a:off x="5734050" y="2223347"/>
+            <a:ext cx="0" cy="575522"/>
+          </a:xfrm>
+          <a:prstGeom prst="straightConnector1">
+            <a:avLst/>
+          </a:prstGeom>
+          <a:ln>
+            <a:tailEnd type="triangle"/>
+          </a:ln>
+        </p:spPr>
+        <p:style>
+          <a:lnRef idx="2">
+            <a:schemeClr val="dk1"/>
+          </a:lnRef>
+          <a:fillRef idx="1">
+            <a:schemeClr val="lt1"/>
+          </a:fillRef>
+          <a:effectRef idx="0">
+            <a:schemeClr val="dk1"/>
+          </a:effectRef>
+          <a:fontRef idx="minor">
+            <a:schemeClr val="dk1"/>
+          </a:fontRef>
+        </p:style>
+      </p:cxnSp>
+      <p:cxnSp>
+        <p:nvCxnSpPr>
+          <p:cNvPr id="29" name="Verbinder: gewinkelt 28">
+            <a:extLst>
+              <a:ext uri="{FF2B5EF4-FFF2-40B4-BE49-F238E27FC236}">
+                <a16:creationId xmlns:a16="http://schemas.microsoft.com/office/drawing/2014/main" id="{E156BA6E-709B-56B8-699B-229D5FA86339}"/>
+              </a:ext>
+            </a:extLst>
+          </p:cNvPr>
+          <p:cNvCxnSpPr>
+            <a:stCxn id="10" idx="2"/>
+            <a:endCxn id="11" idx="1"/>
+          </p:cNvCxnSpPr>
+          <p:nvPr/>
+        </p:nvCxnSpPr>
+        <p:spPr>
+          <a:xfrm rot="16200000" flipH="1">
+            <a:off x="1075320" y="1446054"/>
+            <a:ext cx="287761" cy="857250"/>
+          </a:xfrm>
+          <a:prstGeom prst="bentConnector2">
+            <a:avLst/>
+          </a:prstGeom>
+          <a:ln>
+            <a:tailEnd type="triangle"/>
+          </a:ln>
+        </p:spPr>
+        <p:style>
+          <a:lnRef idx="2">
+            <a:schemeClr val="dk1"/>
+          </a:lnRef>
+          <a:fillRef idx="1">
+            <a:schemeClr val="lt1"/>
+          </a:fillRef>
+          <a:effectRef idx="0">
+            <a:schemeClr val="dk1"/>
+          </a:effectRef>
+          <a:fontRef idx="minor">
+            <a:schemeClr val="dk1"/>
+          </a:fontRef>
+        </p:style>
+      </p:cxnSp>
+      <p:cxnSp>
+        <p:nvCxnSpPr>
+          <p:cNvPr id="31" name="Verbinder: gewinkelt 30">
+            <a:extLst>
+              <a:ext uri="{FF2B5EF4-FFF2-40B4-BE49-F238E27FC236}">
+                <a16:creationId xmlns:a16="http://schemas.microsoft.com/office/drawing/2014/main" id="{B7CD58C2-9CAA-4154-214B-431BD6B803B9}"/>
+              </a:ext>
+            </a:extLst>
+          </p:cNvPr>
+          <p:cNvCxnSpPr>
+            <a:stCxn id="11" idx="2"/>
+            <a:endCxn id="12" idx="1"/>
+          </p:cNvCxnSpPr>
+          <p:nvPr/>
+        </p:nvCxnSpPr>
+        <p:spPr>
+          <a:xfrm rot="16200000" flipH="1">
+            <a:off x="2723144" y="1938603"/>
+            <a:ext cx="287762" cy="857250"/>
+          </a:xfrm>
+          <a:prstGeom prst="bentConnector2">
+            <a:avLst/>
+          </a:prstGeom>
+          <a:ln>
+            <a:tailEnd type="triangle"/>
+          </a:ln>
+        </p:spPr>
+        <p:style>
+          <a:lnRef idx="2">
+            <a:schemeClr val="dk1"/>
+          </a:lnRef>
+          <a:fillRef idx="1">
+            <a:schemeClr val="lt1"/>
+          </a:fillRef>
+          <a:effectRef idx="0">
+            <a:schemeClr val="dk1"/>
+          </a:effectRef>
+          <a:fontRef idx="minor">
+            <a:schemeClr val="dk1"/>
+          </a:fontRef>
+        </p:style>
+      </p:cxnSp>
+      <p:cxnSp>
+        <p:nvCxnSpPr>
+          <p:cNvPr id="33" name="Verbinder: gewinkelt 32">
+            <a:extLst>
+              <a:ext uri="{FF2B5EF4-FFF2-40B4-BE49-F238E27FC236}">
+                <a16:creationId xmlns:a16="http://schemas.microsoft.com/office/drawing/2014/main" id="{4DB9C78F-720D-8D5E-4AEC-7F2E1BA8AECD}"/>
+              </a:ext>
+            </a:extLst>
+          </p:cNvPr>
+          <p:cNvCxnSpPr>
+            <a:stCxn id="12" idx="2"/>
+            <a:endCxn id="13" idx="1"/>
+          </p:cNvCxnSpPr>
+          <p:nvPr/>
+        </p:nvCxnSpPr>
+        <p:spPr>
+          <a:xfrm rot="16200000" flipH="1">
+            <a:off x="4370970" y="2431151"/>
+            <a:ext cx="287761" cy="857250"/>
+          </a:xfrm>
+          <a:prstGeom prst="bentConnector2">
+            <a:avLst/>
+          </a:prstGeom>
+          <a:ln>
+            <a:tailEnd type="triangle"/>
+          </a:ln>
+        </p:spPr>
+        <p:style>
+          <a:lnRef idx="2">
+            <a:schemeClr val="dk1"/>
+          </a:lnRef>
+          <a:fillRef idx="1">
+            <a:schemeClr val="lt1"/>
+          </a:fillRef>
+          <a:effectRef idx="0">
+            <a:schemeClr val="dk1"/>
+          </a:effectRef>
+          <a:fontRef idx="minor">
+            <a:schemeClr val="dk1"/>
+          </a:fontRef>
+        </p:style>
+      </p:cxnSp>
+      <p:pic>
+        <p:nvPicPr>
+          <p:cNvPr id="34" name="Grafik 33">
+            <a:extLst>
+              <a:ext uri="{FF2B5EF4-FFF2-40B4-BE49-F238E27FC236}">
+                <a16:creationId xmlns:a16="http://schemas.microsoft.com/office/drawing/2014/main" id="{E7673B63-9FA9-18BD-8749-47B723208045}"/>
+              </a:ext>
+            </a:extLst>
+          </p:cNvPr>
+          <p:cNvPicPr>
+            <a:picLocks noChangeAspect="1"/>
+          </p:cNvPicPr>
+          <p:nvPr/>
+        </p:nvPicPr>
+        <p:blipFill>
+          <a:blip r:embed="rId3"/>
+          <a:stretch>
+            <a:fillRect/>
+          </a:stretch>
+        </p:blipFill>
+        <p:spPr>
+          <a:xfrm>
+            <a:off x="234412" y="5491503"/>
+            <a:ext cx="6541575" cy="2395936"/>
+          </a:xfrm>
+          <a:prstGeom prst="rect">
+            <a:avLst/>
+          </a:prstGeom>
+        </p:spPr>
+      </p:pic>
+    </p:spTree>
+    <p:extLst>
+      <p:ext uri="{BB962C8B-B14F-4D97-AF65-F5344CB8AC3E}">
+        <p14:creationId xmlns:p14="http://schemas.microsoft.com/office/powerpoint/2010/main" val="1749632522"/>
+      </p:ext>
+    </p:extLst>
+  </p:cSld>
+  <p:clrMapOvr>
+    <a:masterClrMapping/>
+  </p:clrMapOvr>
+</p:sld>
+</file>
+
 <file path=ppt/theme/theme1.xml><?xml version="1.0" encoding="utf-8"?>
 <a:theme xmlns:a="http://schemas.openxmlformats.org/drawingml/2006/main" name="Office">
   <a:themeElements>

</xml_diff>